<commit_message>
fixed typos on slide 28
</commit_message>
<xml_diff>
--- a/Slides/Module 01.2 User Stories.pptx
+++ b/Slides/Module 01.2 User Stories.pptx
@@ -195,6 +195,35 @@
     </p:ext>
   </p:extLst>
 </p:presentation>
+</file>
+
+<file path=ppt/changesInfos/changesInfo1.xml><?xml version="1.0" encoding="utf-8"?>
+<pc:chgInfo xmlns:a="http://schemas.openxmlformats.org/drawingml/2006/main" xmlns:r="http://schemas.openxmlformats.org/officeDocument/2006/relationships" xmlns:ac="http://schemas.microsoft.com/office/drawing/2013/main/command" xmlns:pc="http://schemas.microsoft.com/office/powerpoint/2013/main/command">
+  <pc:docChgLst>
+    <pc:chgData name="Mitchell Wand" userId="de9b44c55c049659" providerId="LiveId" clId="{7A9D5940-B2CC-47DD-AF5E-71219F1A1E26}"/>
+    <pc:docChg chg="modSld">
+      <pc:chgData name="Mitchell Wand" userId="de9b44c55c049659" providerId="LiveId" clId="{7A9D5940-B2CC-47DD-AF5E-71219F1A1E26}" dt="2026-09-09T19:15:25.965" v="4" actId="20577"/>
+      <pc:docMkLst>
+        <pc:docMk/>
+      </pc:docMkLst>
+      <pc:sldChg chg="modSp mod">
+        <pc:chgData name="Mitchell Wand" userId="de9b44c55c049659" providerId="LiveId" clId="{7A9D5940-B2CC-47DD-AF5E-71219F1A1E26}" dt="2026-09-09T19:15:25.965" v="4" actId="20577"/>
+        <pc:sldMkLst>
+          <pc:docMk/>
+          <pc:sldMk cId="1813985170" sldId="585"/>
+        </pc:sldMkLst>
+        <pc:spChg chg="mod">
+          <ac:chgData name="Mitchell Wand" userId="de9b44c55c049659" providerId="LiveId" clId="{7A9D5940-B2CC-47DD-AF5E-71219F1A1E26}" dt="2026-09-09T19:15:25.965" v="4" actId="20577"/>
+          <ac:spMkLst>
+            <pc:docMk/>
+            <pc:sldMk cId="1813985170" sldId="585"/>
+            <ac:spMk id="9" creationId="{154B344C-9133-E9C8-0056-74943F854D75}"/>
+          </ac:spMkLst>
+        </pc:spChg>
+      </pc:sldChg>
+    </pc:docChg>
+  </pc:docChgLst>
+</pc:chgInfo>
 </file>
 
 <file path=ppt/diagrams/colors1.xml><?xml version="1.0" encoding="utf-8"?>
@@ -3685,7 +3714,7 @@
           <a:p>
             <a:fld id="{7C7E5181-6CF5-45F7-A87A-E0E0B1FD7549}" type="datetimeFigureOut">
               <a:rPr lang="en-US" smtClean="0"/>
-              <a:t>8/20/2026</a:t>
+              <a:t>9/9/2026</a:t>
             </a:fld>
             <a:endParaRPr lang="en-US"/>
           </a:p>
@@ -8648,7 +8677,7 @@
           <a:p>
             <a:fld id="{5D2A64DE-480B-420F-9649-4F8E696E08E0}" type="datetime1">
               <a:rPr lang="en-US" smtClean="0"/>
-              <a:t>8/20/2026</a:t>
+              <a:t>9/9/2026</a:t>
             </a:fld>
             <a:endParaRPr lang="en-US"/>
           </a:p>
@@ -8972,7 +9001,7 @@
           <a:p>
             <a:fld id="{EA476A42-A091-4468-A075-64A31BE59948}" type="datetime1">
               <a:rPr lang="en-US" smtClean="0"/>
-              <a:t>8/20/2026</a:t>
+              <a:t>9/9/2026</a:t>
             </a:fld>
             <a:endParaRPr lang="en-US"/>
           </a:p>
@@ -9170,7 +9199,7 @@
           <a:p>
             <a:fld id="{0D3616D0-8311-4107-9726-6B805E7D05BA}" type="datetime1">
               <a:rPr lang="en-US" smtClean="0"/>
-              <a:t>8/20/2026</a:t>
+              <a:t>9/9/2026</a:t>
             </a:fld>
             <a:endParaRPr lang="en-US"/>
           </a:p>
@@ -9378,7 +9407,7 @@
           <a:p>
             <a:fld id="{3BC2557A-5C88-417A-A763-5AC779462A5F}" type="datetime1">
               <a:rPr lang="en-US" smtClean="0"/>
-              <a:t>8/20/2026</a:t>
+              <a:t>9/9/2026</a:t>
             </a:fld>
             <a:endParaRPr lang="en-US"/>
           </a:p>
@@ -9902,7 +9931,7 @@
           <a:p>
             <a:fld id="{07C7BFD4-467E-4EDE-93EA-052F5B39A4E5}" type="datetime1">
               <a:rPr lang="en-US" smtClean="0"/>
-              <a:t>8/20/2026</a:t>
+              <a:t>9/9/2026</a:t>
             </a:fld>
             <a:endParaRPr lang="en-US"/>
           </a:p>
@@ -10152,7 +10181,7 @@
           <a:p>
             <a:fld id="{07C7BFD4-467E-4EDE-93EA-052F5B39A4E5}" type="datetime1">
               <a:rPr lang="en-US" smtClean="0"/>
-              <a:t>8/20/2026</a:t>
+              <a:t>9/9/2026</a:t>
             </a:fld>
             <a:endParaRPr lang="en-US"/>
           </a:p>
@@ -10334,7 +10363,7 @@
           <a:p>
             <a:fld id="{109E55A0-C911-4F03-82FC-7E5926047D46}" type="datetime1">
               <a:rPr lang="en-US" smtClean="0"/>
-              <a:t>8/20/2026</a:t>
+              <a:t>9/9/2026</a:t>
             </a:fld>
             <a:endParaRPr lang="en-US"/>
           </a:p>
@@ -10647,7 +10676,7 @@
           <a:p>
             <a:fld id="{A533CBE2-D5BE-47AC-ADC2-9CDFC1D0CF90}" type="datetime1">
               <a:rPr lang="en-US" smtClean="0"/>
-              <a:t>8/20/2026</a:t>
+              <a:t>9/9/2026</a:t>
             </a:fld>
             <a:endParaRPr lang="en-US"/>
           </a:p>
@@ -10948,7 +10977,7 @@
           <a:p>
             <a:fld id="{39B7EDB1-CE74-4951-85A2-0B01C2128E28}" type="datetime1">
               <a:rPr lang="en-US" smtClean="0"/>
-              <a:t>8/20/2026</a:t>
+              <a:t>9/9/2026</a:t>
             </a:fld>
             <a:endParaRPr lang="en-US"/>
           </a:p>
@@ -11396,7 +11425,7 @@
           <a:p>
             <a:fld id="{2BC7EB92-A5C2-4807-A9DC-9EDE6CBFB241}" type="datetime1">
               <a:rPr lang="en-US" smtClean="0"/>
-              <a:t>8/20/2026</a:t>
+              <a:t>9/9/2026</a:t>
             </a:fld>
             <a:endParaRPr lang="en-US"/>
           </a:p>
@@ -11509,7 +11538,7 @@
           <a:p>
             <a:fld id="{2B7B7EE0-7771-4CD5-9B2B-3550753A54A1}" type="datetime1">
               <a:rPr lang="en-US" smtClean="0"/>
-              <a:t>8/20/2026</a:t>
+              <a:t>9/9/2026</a:t>
             </a:fld>
             <a:endParaRPr lang="en-US"/>
           </a:p>
@@ -11820,7 +11849,7 @@
           <a:p>
             <a:fld id="{F8B318B3-0E87-4416-A9B8-D891968C2727}" type="datetime1">
               <a:rPr lang="en-US" smtClean="0"/>
-              <a:t>8/20/2026</a:t>
+              <a:t>9/9/2026</a:t>
             </a:fld>
             <a:endParaRPr lang="en-US"/>
           </a:p>
@@ -12061,7 +12090,7 @@
           <a:p>
             <a:fld id="{54D997E8-DDEE-43F1-8D9B-F8A1E11DE488}" type="datetime1">
               <a:rPr lang="en-US" smtClean="0"/>
-              <a:t>8/20/2026</a:t>
+              <a:t>9/9/2026</a:t>
             </a:fld>
             <a:endParaRPr lang="en-US"/>
           </a:p>
@@ -18308,40 +18337,43 @@
             </a:r>
             <a:r>
               <a:rPr lang="en-US" dirty="0"/>
-              <a:t>are other properties that are also important to users and to </a:t>
+              <a:t>are other properties that are also important to users and to other stakeholders</a:t>
+            </a:r>
+          </a:p>
+          <a:p>
+            <a:pPr lvl="1"/>
+            <a:r>
+              <a:rPr lang="en-US" dirty="0"/>
+              <a:t>How quickly can a transcript be retrieved? (Performance)</a:t>
+            </a:r>
+          </a:p>
+          <a:p>
+            <a:pPr lvl="1"/>
+            <a:r>
+              <a:rPr lang="en-US" dirty="0"/>
+              <a:t>How many student transcripts can our system store? (Scalability)</a:t>
+            </a:r>
+          </a:p>
+          <a:p>
+            <a:pPr lvl="1"/>
+            <a:r>
+              <a:rPr lang="en-US" dirty="0"/>
+              <a:t>How long did I spend on the phone with support to set up the software? (Usability)</a:t>
+            </a:r>
+          </a:p>
+          <a:p>
+            <a:pPr lvl="1"/>
+            <a:r>
+              <a:rPr lang="en-US" dirty="0"/>
+              <a:t>After my system </a:t>
             </a:r>
             <a:r>
               <a:rPr lang="en-US"/>
-              <a:t>other stakeholders</a:t>
-            </a:r>
-            <a:endParaRPr lang="en-US" dirty="0"/>
-          </a:p>
-          <a:p>
-            <a:pPr lvl="1"/>
-            <a:r>
-              <a:rPr lang="en-US" dirty="0"/>
-              <a:t>How quickly can a transcript be retrieval? (Performance)</a:t>
-            </a:r>
-          </a:p>
-          <a:p>
-            <a:pPr lvl="1"/>
-            <a:r>
-              <a:rPr lang="en-US" dirty="0"/>
-              <a:t>How many student transcripts can our system store? (Scalability)</a:t>
-            </a:r>
-          </a:p>
-          <a:p>
-            <a:pPr lvl="1"/>
-            <a:r>
-              <a:rPr lang="en-US" dirty="0"/>
-              <a:t>How long did I spend on the phone with support to set up the software? (Usability)</a:t>
-            </a:r>
-          </a:p>
-          <a:p>
-            <a:pPr lvl="1"/>
-            <a:r>
-              <a:rPr lang="en-US" dirty="0"/>
-              <a:t>After my system is setup, is the access controlled at all? (Security)</a:t>
+              <a:t>is set up</a:t>
+            </a:r>
+            <a:r>
+              <a:rPr lang="en-US" dirty="0"/>
+              <a:t>, is the access controlled at all? (Security)</a:t>
             </a:r>
           </a:p>
           <a:p>

</xml_diff>

<commit_message>
fixed typos in M01.2, updated Mitch email
</commit_message>
<xml_diff>
--- a/Slides/Module 01.2 User Stories.pptx
+++ b/Slides/Module 01.2 User Stories.pptx
@@ -195,6 +195,35 @@
     </p:ext>
   </p:extLst>
 </p:presentation>
+</file>
+
+<file path=ppt/changesInfos/changesInfo1.xml><?xml version="1.0" encoding="utf-8"?>
+<pc:chgInfo xmlns:a="http://schemas.openxmlformats.org/drawingml/2006/main" xmlns:r="http://schemas.openxmlformats.org/officeDocument/2006/relationships" xmlns:ac="http://schemas.microsoft.com/office/drawing/2013/main/command" xmlns:pc="http://schemas.microsoft.com/office/powerpoint/2013/main/command">
+  <pc:docChgLst>
+    <pc:chgData name="Mitchell Wand" userId="de9b44c55c049659" providerId="LiveId" clId="{7A9D5940-B2CC-47DD-AF5E-71219F1A1E26}"/>
+    <pc:docChg chg="custSel modSld">
+      <pc:chgData name="Mitchell Wand" userId="de9b44c55c049659" providerId="LiveId" clId="{7A9D5940-B2CC-47DD-AF5E-71219F1A1E26}" dt="2026-09-10T02:47:58.756" v="84" actId="20577"/>
+      <pc:docMkLst>
+        <pc:docMk/>
+      </pc:docMkLst>
+      <pc:sldChg chg="modSp mod">
+        <pc:chgData name="Mitchell Wand" userId="de9b44c55c049659" providerId="LiveId" clId="{7A9D5940-B2CC-47DD-AF5E-71219F1A1E26}" dt="2026-09-10T02:47:58.756" v="84" actId="20577"/>
+        <pc:sldMkLst>
+          <pc:docMk/>
+          <pc:sldMk cId="1813985170" sldId="585"/>
+        </pc:sldMkLst>
+        <pc:spChg chg="mod">
+          <ac:chgData name="Mitchell Wand" userId="de9b44c55c049659" providerId="LiveId" clId="{7A9D5940-B2CC-47DD-AF5E-71219F1A1E26}" dt="2026-09-10T02:47:58.756" v="84" actId="20577"/>
+          <ac:spMkLst>
+            <pc:docMk/>
+            <pc:sldMk cId="1813985170" sldId="585"/>
+            <ac:spMk id="9" creationId="{154B344C-9133-E9C8-0056-74943F854D75}"/>
+          </ac:spMkLst>
+        </pc:spChg>
+      </pc:sldChg>
+    </pc:docChg>
+  </pc:docChgLst>
+</pc:chgInfo>
 </file>
 
 <file path=ppt/diagrams/colors1.xml><?xml version="1.0" encoding="utf-8"?>
@@ -3685,7 +3714,7 @@
           <a:p>
             <a:fld id="{7C7E5181-6CF5-45F7-A87A-E0E0B1FD7549}" type="datetimeFigureOut">
               <a:rPr lang="en-US" smtClean="0"/>
-              <a:t>8/20/2026</a:t>
+              <a:t>9/9/2026</a:t>
             </a:fld>
             <a:endParaRPr lang="en-US"/>
           </a:p>
@@ -8648,7 +8677,7 @@
           <a:p>
             <a:fld id="{5D2A64DE-480B-420F-9649-4F8E696E08E0}" type="datetime1">
               <a:rPr lang="en-US" smtClean="0"/>
-              <a:t>8/20/2026</a:t>
+              <a:t>9/9/2026</a:t>
             </a:fld>
             <a:endParaRPr lang="en-US"/>
           </a:p>
@@ -8972,7 +9001,7 @@
           <a:p>
             <a:fld id="{EA476A42-A091-4468-A075-64A31BE59948}" type="datetime1">
               <a:rPr lang="en-US" smtClean="0"/>
-              <a:t>8/20/2026</a:t>
+              <a:t>9/9/2026</a:t>
             </a:fld>
             <a:endParaRPr lang="en-US"/>
           </a:p>
@@ -9170,7 +9199,7 @@
           <a:p>
             <a:fld id="{0D3616D0-8311-4107-9726-6B805E7D05BA}" type="datetime1">
               <a:rPr lang="en-US" smtClean="0"/>
-              <a:t>8/20/2026</a:t>
+              <a:t>9/9/2026</a:t>
             </a:fld>
             <a:endParaRPr lang="en-US"/>
           </a:p>
@@ -9378,7 +9407,7 @@
           <a:p>
             <a:fld id="{3BC2557A-5C88-417A-A763-5AC779462A5F}" type="datetime1">
               <a:rPr lang="en-US" smtClean="0"/>
-              <a:t>8/20/2026</a:t>
+              <a:t>9/9/2026</a:t>
             </a:fld>
             <a:endParaRPr lang="en-US"/>
           </a:p>
@@ -9902,7 +9931,7 @@
           <a:p>
             <a:fld id="{07C7BFD4-467E-4EDE-93EA-052F5B39A4E5}" type="datetime1">
               <a:rPr lang="en-US" smtClean="0"/>
-              <a:t>8/20/2026</a:t>
+              <a:t>9/9/2026</a:t>
             </a:fld>
             <a:endParaRPr lang="en-US"/>
           </a:p>
@@ -10152,7 +10181,7 @@
           <a:p>
             <a:fld id="{07C7BFD4-467E-4EDE-93EA-052F5B39A4E5}" type="datetime1">
               <a:rPr lang="en-US" smtClean="0"/>
-              <a:t>8/20/2026</a:t>
+              <a:t>9/9/2026</a:t>
             </a:fld>
             <a:endParaRPr lang="en-US"/>
           </a:p>
@@ -10334,7 +10363,7 @@
           <a:p>
             <a:fld id="{109E55A0-C911-4F03-82FC-7E5926047D46}" type="datetime1">
               <a:rPr lang="en-US" smtClean="0"/>
-              <a:t>8/20/2026</a:t>
+              <a:t>9/9/2026</a:t>
             </a:fld>
             <a:endParaRPr lang="en-US"/>
           </a:p>
@@ -10647,7 +10676,7 @@
           <a:p>
             <a:fld id="{A533CBE2-D5BE-47AC-ADC2-9CDFC1D0CF90}" type="datetime1">
               <a:rPr lang="en-US" smtClean="0"/>
-              <a:t>8/20/2026</a:t>
+              <a:t>9/9/2026</a:t>
             </a:fld>
             <a:endParaRPr lang="en-US"/>
           </a:p>
@@ -10948,7 +10977,7 @@
           <a:p>
             <a:fld id="{39B7EDB1-CE74-4951-85A2-0B01C2128E28}" type="datetime1">
               <a:rPr lang="en-US" smtClean="0"/>
-              <a:t>8/20/2026</a:t>
+              <a:t>9/9/2026</a:t>
             </a:fld>
             <a:endParaRPr lang="en-US"/>
           </a:p>
@@ -11396,7 +11425,7 @@
           <a:p>
             <a:fld id="{2BC7EB92-A5C2-4807-A9DC-9EDE6CBFB241}" type="datetime1">
               <a:rPr lang="en-US" smtClean="0"/>
-              <a:t>8/20/2026</a:t>
+              <a:t>9/9/2026</a:t>
             </a:fld>
             <a:endParaRPr lang="en-US"/>
           </a:p>
@@ -11509,7 +11538,7 @@
           <a:p>
             <a:fld id="{2B7B7EE0-7771-4CD5-9B2B-3550753A54A1}" type="datetime1">
               <a:rPr lang="en-US" smtClean="0"/>
-              <a:t>8/20/2026</a:t>
+              <a:t>9/9/2026</a:t>
             </a:fld>
             <a:endParaRPr lang="en-US"/>
           </a:p>
@@ -11820,7 +11849,7 @@
           <a:p>
             <a:fld id="{F8B318B3-0E87-4416-A9B8-D891968C2727}" type="datetime1">
               <a:rPr lang="en-US" smtClean="0"/>
-              <a:t>8/20/2026</a:t>
+              <a:t>9/9/2026</a:t>
             </a:fld>
             <a:endParaRPr lang="en-US"/>
           </a:p>
@@ -12061,7 +12090,7 @@
           <a:p>
             <a:fld id="{54D997E8-DDEE-43F1-8D9B-F8A1E11DE488}" type="datetime1">
               <a:rPr lang="en-US" smtClean="0"/>
-              <a:t>8/20/2026</a:t>
+              <a:t>9/9/2026</a:t>
             </a:fld>
             <a:endParaRPr lang="en-US"/>
           </a:p>
@@ -18308,40 +18337,43 @@
             </a:r>
             <a:r>
               <a:rPr lang="en-US" dirty="0"/>
-              <a:t>are other properties that are also important to users and to </a:t>
+              <a:t>are other properties that are also important to users and to other stakeholders</a:t>
+            </a:r>
+          </a:p>
+          <a:p>
+            <a:pPr lvl="1"/>
+            <a:r>
+              <a:rPr lang="en-US" dirty="0"/>
+              <a:t>How quickly can a transcript be retrieved? (Performance)</a:t>
+            </a:r>
+          </a:p>
+          <a:p>
+            <a:pPr lvl="1"/>
+            <a:r>
+              <a:rPr lang="en-US" dirty="0"/>
+              <a:t>How many student transcripts can our system store? (Scalability)</a:t>
+            </a:r>
+          </a:p>
+          <a:p>
+            <a:pPr lvl="1"/>
+            <a:r>
+              <a:rPr lang="en-US" dirty="0"/>
+              <a:t>How much time do I spend on the phone with support to explain how </a:t>
             </a:r>
             <a:r>
               <a:rPr lang="en-US"/>
-              <a:t>other stakeholders</a:t>
-            </a:r>
-            <a:endParaRPr lang="en-US" dirty="0"/>
+              <a:t>to use the </a:t>
+            </a:r>
+            <a:r>
+              <a:rPr lang="en-US" dirty="0"/>
+              <a:t>software? (Usability)</a:t>
+            </a:r>
           </a:p>
           <a:p>
             <a:pPr lvl="1"/>
             <a:r>
               <a:rPr lang="en-US" dirty="0"/>
-              <a:t>How quickly can a transcript be retrieval? (Performance)</a:t>
-            </a:r>
-          </a:p>
-          <a:p>
-            <a:pPr lvl="1"/>
-            <a:r>
-              <a:rPr lang="en-US" dirty="0"/>
-              <a:t>How many student transcripts can our system store? (Scalability)</a:t>
-            </a:r>
-          </a:p>
-          <a:p>
-            <a:pPr lvl="1"/>
-            <a:r>
-              <a:rPr lang="en-US" dirty="0"/>
-              <a:t>How long did I spend on the phone with support to set up the software? (Usability)</a:t>
-            </a:r>
-          </a:p>
-          <a:p>
-            <a:pPr lvl="1"/>
-            <a:r>
-              <a:rPr lang="en-US" dirty="0"/>
-              <a:t>After my system is setup, is the access controlled at all? (Security)</a:t>
+              <a:t>After my system is set up, is the access controlled at all? (Security)</a:t>
             </a:r>
           </a:p>
           <a:p>

</xml_diff>